<commit_message>
Added Database Design Diagram
</commit_message>
<xml_diff>
--- a/Capstone Project Review.pptx
+++ b/Capstone Project Review.pptx
@@ -4546,25 +4546,37 @@
         <p:spPr>
           <a:xfrm>
             <a:off x="759178" y="1151467"/>
-            <a:ext cx="10515600" cy="5025496"/>
+            <a:ext cx="10515600" cy="5441244"/>
           </a:xfrm>
         </p:spPr>
         <p:txBody>
-          <a:bodyPr/>
-          <a:lstStyle/>
-          <a:p>
-            <a:r>
-              <a:rPr lang="en-US" dirty="0"/>
-              <a:t>Fragmented service delivery, lack of real-time tracking, and manual technician assignment processes in traditional home service models.</a:t>
-            </a:r>
-          </a:p>
+          <a:bodyPr>
+            <a:normAutofit fontScale="92500"/>
+          </a:bodyPr>
+          <a:lstStyle/>
           <a:p>
             <a:pPr marL="0" indent="0">
               <a:buNone/>
             </a:pPr>
             <a:r>
               <a:rPr lang="en-US" dirty="0"/>
-              <a:t> </a:t>
+              <a:t>In today’s on-demand home service industry, service providers face significant challenges due to </a:t>
+            </a:r>
+            <a:r>
+              <a:rPr lang="en-US" b="1" dirty="0"/>
+              <a:t>fragmented workflows, manual coordination, and lack of real-time visibility</a:t>
+            </a:r>
+            <a:r>
+              <a:rPr lang="en-US" dirty="0"/>
+              <a:t> across the service lifecycle. Traditional service management approaches rely heavily on </a:t>
+            </a:r>
+            <a:r>
+              <a:rPr lang="en-US" b="1" dirty="0"/>
+              <a:t>disconnected communication channels, and isolated data storage</a:t>
+            </a:r>
+            <a:r>
+              <a:rPr lang="en-US" dirty="0"/>
+              <a:t>, resulting in delayed service delivery, poor customer experience, and limited operational insights. </a:t>
             </a:r>
           </a:p>
           <a:p>
@@ -4860,7 +4872,7 @@
             <a:pPr lvl="1"/>
             <a:r>
               <a:rPr lang="en-US" dirty="0"/>
-              <a:t>Booking Service: Core service lifecycle and dashboarding. </a:t>
+              <a:t>Booking Service: Core service lifecycle and dashboarding.</a:t>
             </a:r>
           </a:p>
           <a:p>

</xml_diff>

<commit_message>
Updated ppt to add business rules slide
</commit_message>
<xml_diff>
--- a/Capstone Project Review.pptx
+++ b/Capstone Project Review.pptx
@@ -13,16 +13,17 @@
     <p:sldId id="261" r:id="rId7"/>
     <p:sldId id="262" r:id="rId8"/>
     <p:sldId id="263" r:id="rId9"/>
-    <p:sldId id="264" r:id="rId10"/>
-    <p:sldId id="265" r:id="rId11"/>
-    <p:sldId id="266" r:id="rId12"/>
-    <p:sldId id="267" r:id="rId13"/>
-    <p:sldId id="268" r:id="rId14"/>
-    <p:sldId id="270" r:id="rId15"/>
-    <p:sldId id="271" r:id="rId16"/>
-    <p:sldId id="273" r:id="rId17"/>
-    <p:sldId id="272" r:id="rId18"/>
-    <p:sldId id="269" r:id="rId19"/>
+    <p:sldId id="274" r:id="rId10"/>
+    <p:sldId id="264" r:id="rId11"/>
+    <p:sldId id="265" r:id="rId12"/>
+    <p:sldId id="266" r:id="rId13"/>
+    <p:sldId id="267" r:id="rId14"/>
+    <p:sldId id="268" r:id="rId15"/>
+    <p:sldId id="270" r:id="rId16"/>
+    <p:sldId id="271" r:id="rId17"/>
+    <p:sldId id="273" r:id="rId18"/>
+    <p:sldId id="272" r:id="rId19"/>
+    <p:sldId id="269" r:id="rId20"/>
   </p:sldIdLst>
   <p:sldSz cx="12192000" cy="6858000"/>
   <p:notesSz cx="6858000" cy="9144000"/>
@@ -276,7 +277,7 @@
           <a:p>
             <a:fld id="{9678DDE2-09C4-447A-9C86-3C371A8CCAF3}" type="datetimeFigureOut">
               <a:rPr lang="en-US" smtClean="0"/>
-              <a:t>1/7/2026</a:t>
+              <a:t>1/8/2026</a:t>
             </a:fld>
             <a:endParaRPr lang="en-US"/>
           </a:p>
@@ -474,7 +475,7 @@
           <a:p>
             <a:fld id="{9678DDE2-09C4-447A-9C86-3C371A8CCAF3}" type="datetimeFigureOut">
               <a:rPr lang="en-US" smtClean="0"/>
-              <a:t>1/7/2026</a:t>
+              <a:t>1/8/2026</a:t>
             </a:fld>
             <a:endParaRPr lang="en-US"/>
           </a:p>
@@ -682,7 +683,7 @@
           <a:p>
             <a:fld id="{9678DDE2-09C4-447A-9C86-3C371A8CCAF3}" type="datetimeFigureOut">
               <a:rPr lang="en-US" smtClean="0"/>
-              <a:t>1/7/2026</a:t>
+              <a:t>1/8/2026</a:t>
             </a:fld>
             <a:endParaRPr lang="en-US"/>
           </a:p>
@@ -880,7 +881,7 @@
           <a:p>
             <a:fld id="{9678DDE2-09C4-447A-9C86-3C371A8CCAF3}" type="datetimeFigureOut">
               <a:rPr lang="en-US" smtClean="0"/>
-              <a:t>1/7/2026</a:t>
+              <a:t>1/8/2026</a:t>
             </a:fld>
             <a:endParaRPr lang="en-US"/>
           </a:p>
@@ -1155,7 +1156,7 @@
           <a:p>
             <a:fld id="{9678DDE2-09C4-447A-9C86-3C371A8CCAF3}" type="datetimeFigureOut">
               <a:rPr lang="en-US" smtClean="0"/>
-              <a:t>1/7/2026</a:t>
+              <a:t>1/8/2026</a:t>
             </a:fld>
             <a:endParaRPr lang="en-US"/>
           </a:p>
@@ -1420,7 +1421,7 @@
           <a:p>
             <a:fld id="{9678DDE2-09C4-447A-9C86-3C371A8CCAF3}" type="datetimeFigureOut">
               <a:rPr lang="en-US" smtClean="0"/>
-              <a:t>1/7/2026</a:t>
+              <a:t>1/8/2026</a:t>
             </a:fld>
             <a:endParaRPr lang="en-US"/>
           </a:p>
@@ -1832,7 +1833,7 @@
           <a:p>
             <a:fld id="{9678DDE2-09C4-447A-9C86-3C371A8CCAF3}" type="datetimeFigureOut">
               <a:rPr lang="en-US" smtClean="0"/>
-              <a:t>1/7/2026</a:t>
+              <a:t>1/8/2026</a:t>
             </a:fld>
             <a:endParaRPr lang="en-US"/>
           </a:p>
@@ -1973,7 +1974,7 @@
           <a:p>
             <a:fld id="{9678DDE2-09C4-447A-9C86-3C371A8CCAF3}" type="datetimeFigureOut">
               <a:rPr lang="en-US" smtClean="0"/>
-              <a:t>1/7/2026</a:t>
+              <a:t>1/8/2026</a:t>
             </a:fld>
             <a:endParaRPr lang="en-US"/>
           </a:p>
@@ -2086,7 +2087,7 @@
           <a:p>
             <a:fld id="{9678DDE2-09C4-447A-9C86-3C371A8CCAF3}" type="datetimeFigureOut">
               <a:rPr lang="en-US" smtClean="0"/>
-              <a:t>1/7/2026</a:t>
+              <a:t>1/8/2026</a:t>
             </a:fld>
             <a:endParaRPr lang="en-US"/>
           </a:p>
@@ -2397,7 +2398,7 @@
           <a:p>
             <a:fld id="{9678DDE2-09C4-447A-9C86-3C371A8CCAF3}" type="datetimeFigureOut">
               <a:rPr lang="en-US" smtClean="0"/>
-              <a:t>1/7/2026</a:t>
+              <a:t>1/8/2026</a:t>
             </a:fld>
             <a:endParaRPr lang="en-US"/>
           </a:p>
@@ -2685,7 +2686,7 @@
           <a:p>
             <a:fld id="{9678DDE2-09C4-447A-9C86-3C371A8CCAF3}" type="datetimeFigureOut">
               <a:rPr lang="en-US" smtClean="0"/>
-              <a:t>1/7/2026</a:t>
+              <a:t>1/8/2026</a:t>
             </a:fld>
             <a:endParaRPr lang="en-US"/>
           </a:p>
@@ -2926,7 +2927,7 @@
           <a:p>
             <a:fld id="{9678DDE2-09C4-447A-9C86-3C371A8CCAF3}" type="datetimeFigureOut">
               <a:rPr lang="en-US" smtClean="0"/>
-              <a:t>1/7/2026</a:t>
+              <a:t>1/8/2026</a:t>
             </a:fld>
             <a:endParaRPr lang="en-US"/>
           </a:p>
@@ -3510,6 +3511,78 @@
           <a:chExt cx="0" cy="0"/>
         </a:xfrm>
       </p:grpSpPr>
+      <p:pic>
+        <p:nvPicPr>
+          <p:cNvPr id="10" name="Content Placeholder 9">
+            <a:extLst>
+              <a:ext uri="{FF2B5EF4-FFF2-40B4-BE49-F238E27FC236}">
+                <a16:creationId xmlns:a16="http://schemas.microsoft.com/office/drawing/2014/main" id="{98554790-F234-6470-FAC1-422564EA7E23}"/>
+              </a:ext>
+            </a:extLst>
+          </p:cNvPr>
+          <p:cNvPicPr>
+            <a:picLocks noGrp="1" noChangeAspect="1"/>
+          </p:cNvPicPr>
+          <p:nvPr>
+            <p:ph idx="1"/>
+          </p:nvPr>
+        </p:nvPicPr>
+        <p:blipFill>
+          <a:blip r:embed="rId2"/>
+          <a:stretch>
+            <a:fillRect/>
+          </a:stretch>
+        </p:blipFill>
+        <p:spPr bwMode="auto">
+          <a:xfrm>
+            <a:off x="127143" y="170610"/>
+            <a:ext cx="11937714" cy="6516780"/>
+          </a:xfrm>
+          <a:prstGeom prst="rect">
+            <a:avLst/>
+          </a:prstGeom>
+          <a:noFill/>
+          <a:extLst>
+            <a:ext uri="{909E8E84-426E-40DD-AFC4-6F175D3DCCD1}">
+              <a14:hiddenFill xmlns:a14="http://schemas.microsoft.com/office/drawing/2010/main">
+                <a:solidFill>
+                  <a:srgbClr val="FFFFFF"/>
+                </a:solidFill>
+              </a14:hiddenFill>
+            </a:ext>
+          </a:extLst>
+        </p:spPr>
+      </p:pic>
+    </p:spTree>
+    <p:extLst>
+      <p:ext uri="{BB962C8B-B14F-4D97-AF65-F5344CB8AC3E}">
+        <p14:creationId xmlns:p14="http://schemas.microsoft.com/office/powerpoint/2010/main" val="2662672783"/>
+      </p:ext>
+    </p:extLst>
+  </p:cSld>
+  <p:clrMapOvr>
+    <a:masterClrMapping/>
+  </p:clrMapOvr>
+</p:sld>
+</file>
+
+<file path=ppt/slides/slide11.xml><?xml version="1.0" encoding="utf-8"?>
+<p:sld xmlns:a="http://schemas.openxmlformats.org/drawingml/2006/main" xmlns:r="http://schemas.openxmlformats.org/officeDocument/2006/relationships" xmlns:p="http://schemas.openxmlformats.org/presentationml/2006/main">
+  <p:cSld>
+    <p:spTree>
+      <p:nvGrpSpPr>
+        <p:cNvPr id="1" name=""/>
+        <p:cNvGrpSpPr/>
+        <p:nvPr/>
+      </p:nvGrpSpPr>
+      <p:grpSpPr>
+        <a:xfrm>
+          <a:off x="0" y="0"/>
+          <a:ext cx="0" cy="0"/>
+          <a:chOff x="0" y="0"/>
+          <a:chExt cx="0" cy="0"/>
+        </a:xfrm>
+      </p:grpSpPr>
       <p:sp>
         <p:nvSpPr>
           <p:cNvPr id="2" name="Title 1">
@@ -3592,7 +3665,7 @@
 </p:sld>
 </file>
 
-<file path=ppt/slides/slide11.xml><?xml version="1.0" encoding="utf-8"?>
+<file path=ppt/slides/slide12.xml><?xml version="1.0" encoding="utf-8"?>
 <p:sld xmlns:a="http://schemas.openxmlformats.org/drawingml/2006/main" xmlns:r="http://schemas.openxmlformats.org/officeDocument/2006/relationships" xmlns:p="http://schemas.openxmlformats.org/presentationml/2006/main">
   <p:cSld>
     <p:spTree>
@@ -3689,7 +3762,7 @@
 </p:sld>
 </file>
 
-<file path=ppt/slides/slide12.xml><?xml version="1.0" encoding="utf-8"?>
+<file path=ppt/slides/slide13.xml><?xml version="1.0" encoding="utf-8"?>
 <p:sld xmlns:a="http://schemas.openxmlformats.org/drawingml/2006/main" xmlns:r="http://schemas.openxmlformats.org/officeDocument/2006/relationships" xmlns:p="http://schemas.openxmlformats.org/presentationml/2006/main">
   <p:cSld>
     <p:spTree>
@@ -3786,7 +3859,7 @@
 </p:sld>
 </file>
 
-<file path=ppt/slides/slide13.xml><?xml version="1.0" encoding="utf-8"?>
+<file path=ppt/slides/slide14.xml><?xml version="1.0" encoding="utf-8"?>
 <p:sld xmlns:a="http://schemas.openxmlformats.org/drawingml/2006/main" xmlns:r="http://schemas.openxmlformats.org/officeDocument/2006/relationships" xmlns:p="http://schemas.openxmlformats.org/presentationml/2006/main">
   <p:cSld>
     <p:spTree>
@@ -3881,112 +3954,6 @@
 </p:sld>
 </file>
 
-<file path=ppt/slides/slide14.xml><?xml version="1.0" encoding="utf-8"?>
-<p:sld xmlns:a="http://schemas.openxmlformats.org/drawingml/2006/main" xmlns:r="http://schemas.openxmlformats.org/officeDocument/2006/relationships" xmlns:p="http://schemas.openxmlformats.org/presentationml/2006/main">
-  <p:cSld>
-    <p:spTree>
-      <p:nvGrpSpPr>
-        <p:cNvPr id="1" name=""/>
-        <p:cNvGrpSpPr/>
-        <p:nvPr/>
-      </p:nvGrpSpPr>
-      <p:grpSpPr>
-        <a:xfrm>
-          <a:off x="0" y="0"/>
-          <a:ext cx="0" cy="0"/>
-          <a:chOff x="0" y="0"/>
-          <a:chExt cx="0" cy="0"/>
-        </a:xfrm>
-      </p:grpSpPr>
-      <p:sp>
-        <p:nvSpPr>
-          <p:cNvPr id="3" name="Content Placeholder 2">
-            <a:extLst>
-              <a:ext uri="{FF2B5EF4-FFF2-40B4-BE49-F238E27FC236}">
-                <a16:creationId xmlns:a16="http://schemas.microsoft.com/office/drawing/2014/main" id="{0C18DAC9-F6DC-F647-A6BE-90D8E01126EB}"/>
-              </a:ext>
-            </a:extLst>
-          </p:cNvPr>
-          <p:cNvSpPr>
-            <a:spLocks noGrp="1"/>
-          </p:cNvSpPr>
-          <p:nvPr>
-            <p:ph idx="1"/>
-          </p:nvPr>
-        </p:nvSpPr>
-        <p:spPr>
-          <a:xfrm>
-            <a:off x="939800" y="634029"/>
-            <a:ext cx="10515600" cy="5589941"/>
-          </a:xfrm>
-        </p:spPr>
-        <p:txBody>
-          <a:bodyPr>
-            <a:normAutofit/>
-          </a:bodyPr>
-          <a:lstStyle/>
-          <a:p>
-            <a:pPr marL="0" indent="0">
-              <a:buNone/>
-            </a:pPr>
-            <a:r>
-              <a:rPr lang="en-US" b="1" dirty="0"/>
-              <a:t>Testing &amp; Quality</a:t>
-            </a:r>
-          </a:p>
-          <a:p>
-            <a:endParaRPr lang="en-US" dirty="0"/>
-          </a:p>
-          <a:p>
-            <a:r>
-              <a:rPr lang="en-US" dirty="0"/>
-              <a:t>Unit &amp; Integration Testing: Extensive test coverage using </a:t>
-            </a:r>
-            <a:r>
-              <a:rPr lang="en-US" dirty="0" err="1"/>
-              <a:t>MockMvc</a:t>
-            </a:r>
-            <a:r>
-              <a:rPr lang="en-US" dirty="0"/>
-              <a:t> for controllers and Mockito for service-layer isolation. </a:t>
-            </a:r>
-          </a:p>
-          <a:p>
-            <a:endParaRPr lang="en-US" dirty="0"/>
-          </a:p>
-          <a:p>
-            <a:r>
-              <a:rPr lang="en-US" dirty="0"/>
-              <a:t>Security Testing: Use of @WithMockUser to validate role-based access constraints (e.g., ensuring technicians cannot assign tasks). </a:t>
-            </a:r>
-          </a:p>
-          <a:p>
-            <a:pPr marL="0" indent="0">
-              <a:buNone/>
-            </a:pPr>
-            <a:endParaRPr lang="en-US" dirty="0"/>
-          </a:p>
-          <a:p>
-            <a:r>
-              <a:rPr lang="en-US" dirty="0"/>
-              <a:t>Validation: Strict input validation using JSR-303 annotations (@NotBlank, @Pattern, @Size)</a:t>
-            </a:r>
-          </a:p>
-        </p:txBody>
-      </p:sp>
-    </p:spTree>
-    <p:extLst>
-      <p:ext uri="{BB962C8B-B14F-4D97-AF65-F5344CB8AC3E}">
-        <p14:creationId xmlns:p14="http://schemas.microsoft.com/office/powerpoint/2010/main" val="2826921074"/>
-      </p:ext>
-    </p:extLst>
-  </p:cSld>
-  <p:clrMapOvr>
-    <a:masterClrMapping/>
-  </p:clrMapOvr>
-</p:sld>
-</file>
-
 <file path=ppt/slides/slide15.xml><?xml version="1.0" encoding="utf-8"?>
 <p:sld xmlns:a="http://schemas.openxmlformats.org/drawingml/2006/main" xmlns:r="http://schemas.openxmlformats.org/officeDocument/2006/relationships" xmlns:p="http://schemas.openxmlformats.org/presentationml/2006/main">
   <p:cSld>
@@ -4009,6 +3976,112 @@
           <p:cNvPr id="3" name="Content Placeholder 2">
             <a:extLst>
               <a:ext uri="{FF2B5EF4-FFF2-40B4-BE49-F238E27FC236}">
+                <a16:creationId xmlns:a16="http://schemas.microsoft.com/office/drawing/2014/main" id="{0C18DAC9-F6DC-F647-A6BE-90D8E01126EB}"/>
+              </a:ext>
+            </a:extLst>
+          </p:cNvPr>
+          <p:cNvSpPr>
+            <a:spLocks noGrp="1"/>
+          </p:cNvSpPr>
+          <p:nvPr>
+            <p:ph idx="1"/>
+          </p:nvPr>
+        </p:nvSpPr>
+        <p:spPr>
+          <a:xfrm>
+            <a:off x="939800" y="634029"/>
+            <a:ext cx="10515600" cy="5589941"/>
+          </a:xfrm>
+        </p:spPr>
+        <p:txBody>
+          <a:bodyPr>
+            <a:normAutofit/>
+          </a:bodyPr>
+          <a:lstStyle/>
+          <a:p>
+            <a:pPr marL="0" indent="0">
+              <a:buNone/>
+            </a:pPr>
+            <a:r>
+              <a:rPr lang="en-US" b="1" dirty="0"/>
+              <a:t>Testing &amp; Quality</a:t>
+            </a:r>
+          </a:p>
+          <a:p>
+            <a:endParaRPr lang="en-US" dirty="0"/>
+          </a:p>
+          <a:p>
+            <a:r>
+              <a:rPr lang="en-US" dirty="0"/>
+              <a:t>Unit &amp; Integration Testing: Extensive test coverage using </a:t>
+            </a:r>
+            <a:r>
+              <a:rPr lang="en-US" dirty="0" err="1"/>
+              <a:t>MockMvc</a:t>
+            </a:r>
+            <a:r>
+              <a:rPr lang="en-US" dirty="0"/>
+              <a:t> for controllers and Mockito for service-layer isolation. </a:t>
+            </a:r>
+          </a:p>
+          <a:p>
+            <a:endParaRPr lang="en-US" dirty="0"/>
+          </a:p>
+          <a:p>
+            <a:r>
+              <a:rPr lang="en-US" dirty="0"/>
+              <a:t>Security Testing: Use of @WithMockUser to validate role-based access constraints (e.g., ensuring technicians cannot assign tasks). </a:t>
+            </a:r>
+          </a:p>
+          <a:p>
+            <a:pPr marL="0" indent="0">
+              <a:buNone/>
+            </a:pPr>
+            <a:endParaRPr lang="en-US" dirty="0"/>
+          </a:p>
+          <a:p>
+            <a:r>
+              <a:rPr lang="en-US" dirty="0"/>
+              <a:t>Validation: Strict input validation using JSR-303 annotations (@NotBlank, @Pattern, @Size)</a:t>
+            </a:r>
+          </a:p>
+        </p:txBody>
+      </p:sp>
+    </p:spTree>
+    <p:extLst>
+      <p:ext uri="{BB962C8B-B14F-4D97-AF65-F5344CB8AC3E}">
+        <p14:creationId xmlns:p14="http://schemas.microsoft.com/office/powerpoint/2010/main" val="2826921074"/>
+      </p:ext>
+    </p:extLst>
+  </p:cSld>
+  <p:clrMapOvr>
+    <a:masterClrMapping/>
+  </p:clrMapOvr>
+</p:sld>
+</file>
+
+<file path=ppt/slides/slide16.xml><?xml version="1.0" encoding="utf-8"?>
+<p:sld xmlns:a="http://schemas.openxmlformats.org/drawingml/2006/main" xmlns:r="http://schemas.openxmlformats.org/officeDocument/2006/relationships" xmlns:p="http://schemas.openxmlformats.org/presentationml/2006/main">
+  <p:cSld>
+    <p:spTree>
+      <p:nvGrpSpPr>
+        <p:cNvPr id="1" name=""/>
+        <p:cNvGrpSpPr/>
+        <p:nvPr/>
+      </p:nvGrpSpPr>
+      <p:grpSpPr>
+        <a:xfrm>
+          <a:off x="0" y="0"/>
+          <a:ext cx="0" cy="0"/>
+          <a:chOff x="0" y="0"/>
+          <a:chExt cx="0" cy="0"/>
+        </a:xfrm>
+      </p:grpSpPr>
+      <p:sp>
+        <p:nvSpPr>
+          <p:cNvPr id="3" name="Content Placeholder 2">
+            <a:extLst>
+              <a:ext uri="{FF2B5EF4-FFF2-40B4-BE49-F238E27FC236}">
                 <a16:creationId xmlns:a16="http://schemas.microsoft.com/office/drawing/2014/main" id="{6B88E7FB-0FF1-650C-30E0-E0A43E65F833}"/>
               </a:ext>
             </a:extLst>
@@ -4114,7 +4187,7 @@
 </p:sld>
 </file>
 
-<file path=ppt/slides/slide16.xml><?xml version="1.0" encoding="utf-8"?>
+<file path=ppt/slides/slide17.xml><?xml version="1.0" encoding="utf-8"?>
 <p:sld xmlns:a="http://schemas.openxmlformats.org/drawingml/2006/main" xmlns:r="http://schemas.openxmlformats.org/officeDocument/2006/relationships" xmlns:p="http://schemas.openxmlformats.org/presentationml/2006/main">
   <p:cSld>
     <p:spTree>
@@ -4303,7 +4376,7 @@
 </p:sld>
 </file>
 
-<file path=ppt/slides/slide17.xml><?xml version="1.0" encoding="utf-8"?>
+<file path=ppt/slides/slide18.xml><?xml version="1.0" encoding="utf-8"?>
 <p:sld xmlns:a="http://schemas.openxmlformats.org/drawingml/2006/main" xmlns:r="http://schemas.openxmlformats.org/officeDocument/2006/relationships" xmlns:p="http://schemas.openxmlformats.org/presentationml/2006/main">
   <p:cSld>
     <p:spTree>
@@ -4398,7 +4471,7 @@
 </p:sld>
 </file>
 
-<file path=ppt/slides/slide18.xml><?xml version="1.0" encoding="utf-8"?>
+<file path=ppt/slides/slide19.xml><?xml version="1.0" encoding="utf-8"?>
 <p:sld xmlns:a="http://schemas.openxmlformats.org/drawingml/2006/main" xmlns:r="http://schemas.openxmlformats.org/officeDocument/2006/relationships" xmlns:p="http://schemas.openxmlformats.org/presentationml/2006/main">
   <p:cSld>
     <p:spTree>
@@ -5080,7 +5153,7 @@
         </p:blipFill>
         <p:spPr>
           <a:xfrm>
-            <a:off x="628997" y="889143"/>
+            <a:off x="741886" y="708521"/>
             <a:ext cx="10934006" cy="5968857"/>
           </a:xfrm>
           <a:prstGeom prst="rect">
@@ -5456,52 +5529,920 @@
           <a:chExt cx="0" cy="0"/>
         </a:xfrm>
       </p:grpSpPr>
-      <p:pic>
-        <p:nvPicPr>
-          <p:cNvPr id="10" name="Content Placeholder 9">
-            <a:extLst>
-              <a:ext uri="{FF2B5EF4-FFF2-40B4-BE49-F238E27FC236}">
-                <a16:creationId xmlns:a16="http://schemas.microsoft.com/office/drawing/2014/main" id="{98554790-F234-6470-FAC1-422564EA7E23}"/>
-              </a:ext>
-            </a:extLst>
-          </p:cNvPr>
-          <p:cNvPicPr>
-            <a:picLocks noGrp="1" noChangeAspect="1"/>
-          </p:cNvPicPr>
+      <p:graphicFrame>
+        <p:nvGraphicFramePr>
+          <p:cNvPr id="4" name="Content Placeholder 3">
+            <a:extLst>
+              <a:ext uri="{FF2B5EF4-FFF2-40B4-BE49-F238E27FC236}">
+                <a16:creationId xmlns:a16="http://schemas.microsoft.com/office/drawing/2014/main" id="{F5A4A964-9B2A-1C3E-0068-8BEE7810A2A6}"/>
+              </a:ext>
+            </a:extLst>
+          </p:cNvPr>
+          <p:cNvGraphicFramePr>
+            <a:graphicFrameLocks noGrp="1"/>
+          </p:cNvGraphicFramePr>
           <p:nvPr>
             <p:ph idx="1"/>
-          </p:nvPr>
-        </p:nvPicPr>
-        <p:blipFill>
-          <a:blip r:embed="rId2"/>
-          <a:stretch>
-            <a:fillRect/>
-          </a:stretch>
-        </p:blipFill>
-        <p:spPr bwMode="auto">
-          <a:xfrm>
-            <a:off x="127143" y="170610"/>
-            <a:ext cx="11937714" cy="6516780"/>
-          </a:xfrm>
-          <a:prstGeom prst="rect">
-            <a:avLst/>
-          </a:prstGeom>
-          <a:noFill/>
-          <a:extLst>
-            <a:ext uri="{909E8E84-426E-40DD-AFC4-6F175D3DCCD1}">
-              <a14:hiddenFill xmlns:a14="http://schemas.microsoft.com/office/drawing/2010/main">
-                <a:solidFill>
-                  <a:srgbClr val="FFFFFF"/>
-                </a:solidFill>
-              </a14:hiddenFill>
-            </a:ext>
-          </a:extLst>
-        </p:spPr>
-      </p:pic>
+            <p:extLst>
+              <p:ext uri="{D42A27DB-BD31-4B8C-83A1-F6EECF244321}">
+                <p14:modId xmlns:p14="http://schemas.microsoft.com/office/powerpoint/2010/main" val="1503694289"/>
+              </p:ext>
+            </p:extLst>
+          </p:nvPr>
+        </p:nvGraphicFramePr>
+        <p:xfrm>
+          <a:off x="1501422" y="0"/>
+          <a:ext cx="8726311" cy="6858001"/>
+        </p:xfrm>
+        <a:graphic>
+          <a:graphicData uri="http://schemas.openxmlformats.org/drawingml/2006/table">
+            <a:tbl>
+              <a:tblPr/>
+              <a:tblGrid>
+                <a:gridCol w="3359812">
+                  <a:extLst>
+                    <a:ext uri="{9D8B030D-6E8A-4147-A177-3AD203B41FA5}">
+                      <a16:colId xmlns:a16="http://schemas.microsoft.com/office/drawing/2014/main" val="256367331"/>
+                    </a:ext>
+                  </a:extLst>
+                </a:gridCol>
+                <a:gridCol w="5366499">
+                  <a:extLst>
+                    <a:ext uri="{9D8B030D-6E8A-4147-A177-3AD203B41FA5}">
+                      <a16:colId xmlns:a16="http://schemas.microsoft.com/office/drawing/2014/main" val="3707909846"/>
+                    </a:ext>
+                  </a:extLst>
+                </a:gridCol>
+              </a:tblGrid>
+              <a:tr h="500898">
+                <a:tc>
+                  <a:txBody>
+                    <a:bodyPr/>
+                    <a:lstStyle/>
+                    <a:p>
+                      <a:pPr rtl="0">
+                        <a:buNone/>
+                      </a:pPr>
+                      <a:r>
+                        <a:rPr lang="en-US" sz="1500" b="1" dirty="0">
+                          <a:solidFill>
+                            <a:srgbClr val="1F1F1F"/>
+                          </a:solidFill>
+                          <a:effectLst/>
+                          <a:latin typeface="Google Sans Text"/>
+                        </a:rPr>
+                        <a:t>Feature</a:t>
+                      </a:r>
+                      <a:endParaRPr lang="en-US" sz="1500" dirty="0">
+                        <a:solidFill>
+                          <a:srgbClr val="1F1F1F"/>
+                        </a:solidFill>
+                        <a:effectLst/>
+                        <a:latin typeface="Google Sans Text"/>
+                      </a:endParaRPr>
+                    </a:p>
+                  </a:txBody>
+                  <a:tcPr marL="73751" marR="73751" marT="49168" marB="49168" anchor="ctr">
+                    <a:lnL w="7620" cap="flat" cmpd="sng" algn="ctr">
+                      <a:solidFill>
+                        <a:schemeClr val="bg1"/>
+                      </a:solidFill>
+                      <a:prstDash val="solid"/>
+                      <a:round/>
+                      <a:headEnd type="none" w="med" len="med"/>
+                      <a:tailEnd type="none" w="med" len="med"/>
+                    </a:lnL>
+                    <a:lnR w="7620" cap="flat" cmpd="sng" algn="ctr">
+                      <a:solidFill>
+                        <a:schemeClr val="bg1"/>
+                      </a:solidFill>
+                      <a:prstDash val="solid"/>
+                      <a:round/>
+                      <a:headEnd type="none" w="med" len="med"/>
+                      <a:tailEnd type="none" w="med" len="med"/>
+                    </a:lnR>
+                    <a:lnT w="7620" cap="flat" cmpd="sng" algn="ctr">
+                      <a:solidFill>
+                        <a:schemeClr val="bg1"/>
+                      </a:solidFill>
+                      <a:prstDash val="solid"/>
+                      <a:round/>
+                      <a:headEnd type="none" w="med" len="med"/>
+                      <a:tailEnd type="none" w="med" len="med"/>
+                    </a:lnT>
+                    <a:lnB w="7620" cap="flat" cmpd="sng" algn="ctr">
+                      <a:solidFill>
+                        <a:schemeClr val="bg1"/>
+                      </a:solidFill>
+                      <a:prstDash val="solid"/>
+                      <a:round/>
+                      <a:headEnd type="none" w="med" len="med"/>
+                      <a:tailEnd type="none" w="med" len="med"/>
+                    </a:lnB>
+                    <a:noFill/>
+                  </a:tcPr>
+                </a:tc>
+                <a:tc>
+                  <a:txBody>
+                    <a:bodyPr/>
+                    <a:lstStyle/>
+                    <a:p>
+                      <a:pPr rtl="0">
+                        <a:buNone/>
+                      </a:pPr>
+                      <a:r>
+                        <a:rPr lang="en-US" sz="1500" b="1">
+                          <a:solidFill>
+                            <a:srgbClr val="1F1F1F"/>
+                          </a:solidFill>
+                          <a:effectLst/>
+                          <a:latin typeface="Google Sans Text"/>
+                        </a:rPr>
+                        <a:t>Business Rule (The "Why")</a:t>
+                      </a:r>
+                      <a:endParaRPr lang="en-US" sz="1500">
+                        <a:solidFill>
+                          <a:srgbClr val="1F1F1F"/>
+                        </a:solidFill>
+                        <a:effectLst/>
+                        <a:latin typeface="Google Sans Text"/>
+                      </a:endParaRPr>
+                    </a:p>
+                  </a:txBody>
+                  <a:tcPr marL="73751" marR="73751" marT="49168" marB="49168" anchor="ctr">
+                    <a:lnL w="7620" cap="flat" cmpd="sng" algn="ctr">
+                      <a:solidFill>
+                        <a:schemeClr val="bg1"/>
+                      </a:solidFill>
+                      <a:prstDash val="solid"/>
+                      <a:round/>
+                      <a:headEnd type="none" w="med" len="med"/>
+                      <a:tailEnd type="none" w="med" len="med"/>
+                    </a:lnL>
+                    <a:lnR w="7620" cap="flat" cmpd="sng" algn="ctr">
+                      <a:solidFill>
+                        <a:schemeClr val="bg1"/>
+                      </a:solidFill>
+                      <a:prstDash val="solid"/>
+                      <a:round/>
+                      <a:headEnd type="none" w="med" len="med"/>
+                      <a:tailEnd type="none" w="med" len="med"/>
+                    </a:lnR>
+                    <a:lnT w="7620" cap="flat" cmpd="sng" algn="ctr">
+                      <a:solidFill>
+                        <a:schemeClr val="bg1"/>
+                      </a:solidFill>
+                      <a:prstDash val="solid"/>
+                      <a:round/>
+                      <a:headEnd type="none" w="med" len="med"/>
+                      <a:tailEnd type="none" w="med" len="med"/>
+                    </a:lnT>
+                    <a:lnB w="7620" cap="flat" cmpd="sng" algn="ctr">
+                      <a:solidFill>
+                        <a:schemeClr val="bg1"/>
+                      </a:solidFill>
+                      <a:prstDash val="solid"/>
+                      <a:round/>
+                      <a:headEnd type="none" w="med" len="med"/>
+                      <a:tailEnd type="none" w="med" len="med"/>
+                    </a:lnB>
+                    <a:noFill/>
+                  </a:tcPr>
+                </a:tc>
+                <a:extLst>
+                  <a:ext uri="{0D108BD9-81ED-4DB2-BD59-A6C34878D82A}">
+                    <a16:rowId xmlns:a16="http://schemas.microsoft.com/office/drawing/2014/main" val="3273157196"/>
+                  </a:ext>
+                </a:extLst>
+              </a:tr>
+              <a:tr h="1201373">
+                <a:tc>
+                  <a:txBody>
+                    <a:bodyPr/>
+                    <a:lstStyle/>
+                    <a:p>
+                      <a:pPr rtl="0">
+                        <a:buNone/>
+                      </a:pPr>
+                      <a:r>
+                        <a:rPr lang="en-US" sz="1500" b="1">
+                          <a:solidFill>
+                            <a:srgbClr val="1F1F1F"/>
+                          </a:solidFill>
+                          <a:effectLst/>
+                          <a:latin typeface="Google Sans Text"/>
+                        </a:rPr>
+                        <a:t>Technician Approval</a:t>
+                      </a:r>
+                      <a:endParaRPr lang="en-US" sz="1500">
+                        <a:solidFill>
+                          <a:srgbClr val="1F1F1F"/>
+                        </a:solidFill>
+                        <a:effectLst/>
+                        <a:latin typeface="Google Sans Text"/>
+                      </a:endParaRPr>
+                    </a:p>
+                  </a:txBody>
+                  <a:tcPr marL="73751" marR="73751" marT="49168" marB="49168" anchor="ctr">
+                    <a:lnL w="7620" cap="flat" cmpd="sng" algn="ctr">
+                      <a:solidFill>
+                        <a:schemeClr val="bg1"/>
+                      </a:solidFill>
+                      <a:prstDash val="solid"/>
+                      <a:round/>
+                      <a:headEnd type="none" w="med" len="med"/>
+                      <a:tailEnd type="none" w="med" len="med"/>
+                    </a:lnL>
+                    <a:lnR w="7620" cap="flat" cmpd="sng" algn="ctr">
+                      <a:solidFill>
+                        <a:schemeClr val="bg1"/>
+                      </a:solidFill>
+                      <a:prstDash val="solid"/>
+                      <a:round/>
+                      <a:headEnd type="none" w="med" len="med"/>
+                      <a:tailEnd type="none" w="med" len="med"/>
+                    </a:lnR>
+                    <a:lnT w="7620" cap="flat" cmpd="sng" algn="ctr">
+                      <a:solidFill>
+                        <a:schemeClr val="bg1"/>
+                      </a:solidFill>
+                      <a:prstDash val="solid"/>
+                      <a:round/>
+                      <a:headEnd type="none" w="med" len="med"/>
+                      <a:tailEnd type="none" w="med" len="med"/>
+                    </a:lnT>
+                    <a:lnB w="7620" cap="flat" cmpd="sng" algn="ctr">
+                      <a:solidFill>
+                        <a:schemeClr val="bg1"/>
+                      </a:solidFill>
+                      <a:prstDash val="solid"/>
+                      <a:round/>
+                      <a:headEnd type="none" w="med" len="med"/>
+                      <a:tailEnd type="none" w="med" len="med"/>
+                    </a:lnB>
+                    <a:noFill/>
+                  </a:tcPr>
+                </a:tc>
+                <a:tc>
+                  <a:txBody>
+                    <a:bodyPr/>
+                    <a:lstStyle/>
+                    <a:p>
+                      <a:pPr rtl="0">
+                        <a:buNone/>
+                      </a:pPr>
+                      <a:r>
+                        <a:rPr lang="en-US" sz="1500" b="1">
+                          <a:solidFill>
+                            <a:srgbClr val="1F1F1F"/>
+                          </a:solidFill>
+                          <a:effectLst/>
+                          <a:latin typeface="Google Sans Text"/>
+                        </a:rPr>
+                        <a:t>Quality Control.</a:t>
+                      </a:r>
+                      <a:r>
+                        <a:rPr lang="en-US" sz="1500">
+                          <a:solidFill>
+                            <a:srgbClr val="1F1F1F"/>
+                          </a:solidFill>
+                          <a:effectLst/>
+                          <a:latin typeface="Google Sans Text"/>
+                        </a:rPr>
+                        <a:t> Random people cannot just sign up and enter customers' homes.</a:t>
+                      </a:r>
+                    </a:p>
+                  </a:txBody>
+                  <a:tcPr marL="73751" marR="73751" marT="49168" marB="49168" anchor="ctr">
+                    <a:lnL w="7620" cap="flat" cmpd="sng" algn="ctr">
+                      <a:solidFill>
+                        <a:schemeClr val="bg1"/>
+                      </a:solidFill>
+                      <a:prstDash val="solid"/>
+                      <a:round/>
+                      <a:headEnd type="none" w="med" len="med"/>
+                      <a:tailEnd type="none" w="med" len="med"/>
+                    </a:lnL>
+                    <a:lnR w="7620" cap="flat" cmpd="sng" algn="ctr">
+                      <a:solidFill>
+                        <a:schemeClr val="bg1"/>
+                      </a:solidFill>
+                      <a:prstDash val="solid"/>
+                      <a:round/>
+                      <a:headEnd type="none" w="med" len="med"/>
+                      <a:tailEnd type="none" w="med" len="med"/>
+                    </a:lnR>
+                    <a:lnT w="7620" cap="flat" cmpd="sng" algn="ctr">
+                      <a:solidFill>
+                        <a:schemeClr val="bg1"/>
+                      </a:solidFill>
+                      <a:prstDash val="solid"/>
+                      <a:round/>
+                      <a:headEnd type="none" w="med" len="med"/>
+                      <a:tailEnd type="none" w="med" len="med"/>
+                    </a:lnT>
+                    <a:lnB w="7620" cap="flat" cmpd="sng" algn="ctr">
+                      <a:solidFill>
+                        <a:schemeClr val="bg1"/>
+                      </a:solidFill>
+                      <a:prstDash val="solid"/>
+                      <a:round/>
+                      <a:headEnd type="none" w="med" len="med"/>
+                      <a:tailEnd type="none" w="med" len="med"/>
+                    </a:lnB>
+                    <a:noFill/>
+                  </a:tcPr>
+                </a:tc>
+                <a:extLst>
+                  <a:ext uri="{0D108BD9-81ED-4DB2-BD59-A6C34878D82A}">
+                    <a16:rowId xmlns:a16="http://schemas.microsoft.com/office/drawing/2014/main" val="1128015386"/>
+                  </a:ext>
+                </a:extLst>
+              </a:tr>
+              <a:tr h="1551611">
+                <a:tc>
+                  <a:txBody>
+                    <a:bodyPr/>
+                    <a:lstStyle/>
+                    <a:p>
+                      <a:pPr rtl="0">
+                        <a:buNone/>
+                      </a:pPr>
+                      <a:r>
+                        <a:rPr lang="en-US" sz="1500" b="1">
+                          <a:solidFill>
+                            <a:srgbClr val="1F1F1F"/>
+                          </a:solidFill>
+                          <a:effectLst/>
+                          <a:latin typeface="Google Sans Text"/>
+                        </a:rPr>
+                        <a:t>OTP Completion</a:t>
+                      </a:r>
+                      <a:endParaRPr lang="en-US" sz="1500">
+                        <a:solidFill>
+                          <a:srgbClr val="1F1F1F"/>
+                        </a:solidFill>
+                        <a:effectLst/>
+                        <a:latin typeface="Google Sans Text"/>
+                      </a:endParaRPr>
+                    </a:p>
+                  </a:txBody>
+                  <a:tcPr marL="73751" marR="73751" marT="49168" marB="49168" anchor="ctr">
+                    <a:lnL w="7620" cap="flat" cmpd="sng" algn="ctr">
+                      <a:solidFill>
+                        <a:schemeClr val="bg1"/>
+                      </a:solidFill>
+                      <a:prstDash val="solid"/>
+                      <a:round/>
+                      <a:headEnd type="none" w="med" len="med"/>
+                      <a:tailEnd type="none" w="med" len="med"/>
+                    </a:lnL>
+                    <a:lnR w="7620" cap="flat" cmpd="sng" algn="ctr">
+                      <a:solidFill>
+                        <a:schemeClr val="bg1"/>
+                      </a:solidFill>
+                      <a:prstDash val="solid"/>
+                      <a:round/>
+                      <a:headEnd type="none" w="med" len="med"/>
+                      <a:tailEnd type="none" w="med" len="med"/>
+                    </a:lnR>
+                    <a:lnT w="7620" cap="flat" cmpd="sng" algn="ctr">
+                      <a:solidFill>
+                        <a:schemeClr val="bg1"/>
+                      </a:solidFill>
+                      <a:prstDash val="solid"/>
+                      <a:round/>
+                      <a:headEnd type="none" w="med" len="med"/>
+                      <a:tailEnd type="none" w="med" len="med"/>
+                    </a:lnT>
+                    <a:lnB w="7620" cap="flat" cmpd="sng" algn="ctr">
+                      <a:solidFill>
+                        <a:schemeClr val="bg1"/>
+                      </a:solidFill>
+                      <a:prstDash val="solid"/>
+                      <a:round/>
+                      <a:headEnd type="none" w="med" len="med"/>
+                      <a:tailEnd type="none" w="med" len="med"/>
+                    </a:lnB>
+                    <a:noFill/>
+                  </a:tcPr>
+                </a:tc>
+                <a:tc>
+                  <a:txBody>
+                    <a:bodyPr/>
+                    <a:lstStyle/>
+                    <a:p>
+                      <a:pPr rtl="0">
+                        <a:buNone/>
+                      </a:pPr>
+                      <a:r>
+                        <a:rPr lang="en-US" sz="1500" b="1" dirty="0">
+                          <a:solidFill>
+                            <a:srgbClr val="1F1F1F"/>
+                          </a:solidFill>
+                          <a:effectLst/>
+                          <a:latin typeface="Google Sans Text"/>
+                        </a:rPr>
+                        <a:t>Fraud Prevention.</a:t>
+                      </a:r>
+                      <a:r>
+                        <a:rPr lang="en-US" sz="1500" dirty="0">
+                          <a:solidFill>
+                            <a:srgbClr val="1F1F1F"/>
+                          </a:solidFill>
+                          <a:effectLst/>
+                          <a:latin typeface="Google Sans Text"/>
+                        </a:rPr>
+                        <a:t> Prevents technicians from marking a job "Done" without actually visiting the house.</a:t>
+                      </a:r>
+                    </a:p>
+                  </a:txBody>
+                  <a:tcPr marL="73751" marR="73751" marT="49168" marB="49168" anchor="ctr">
+                    <a:lnL w="7620" cap="flat" cmpd="sng" algn="ctr">
+                      <a:solidFill>
+                        <a:schemeClr val="bg1"/>
+                      </a:solidFill>
+                      <a:prstDash val="solid"/>
+                      <a:round/>
+                      <a:headEnd type="none" w="med" len="med"/>
+                      <a:tailEnd type="none" w="med" len="med"/>
+                    </a:lnL>
+                    <a:lnR w="7620" cap="flat" cmpd="sng" algn="ctr">
+                      <a:solidFill>
+                        <a:schemeClr val="bg1"/>
+                      </a:solidFill>
+                      <a:prstDash val="solid"/>
+                      <a:round/>
+                      <a:headEnd type="none" w="med" len="med"/>
+                      <a:tailEnd type="none" w="med" len="med"/>
+                    </a:lnR>
+                    <a:lnT w="7620" cap="flat" cmpd="sng" algn="ctr">
+                      <a:solidFill>
+                        <a:schemeClr val="bg1"/>
+                      </a:solidFill>
+                      <a:prstDash val="solid"/>
+                      <a:round/>
+                      <a:headEnd type="none" w="med" len="med"/>
+                      <a:tailEnd type="none" w="med" len="med"/>
+                    </a:lnT>
+                    <a:lnB w="7620" cap="flat" cmpd="sng" algn="ctr">
+                      <a:solidFill>
+                        <a:schemeClr val="bg1"/>
+                      </a:solidFill>
+                      <a:prstDash val="solid"/>
+                      <a:round/>
+                      <a:headEnd type="none" w="med" len="med"/>
+                      <a:tailEnd type="none" w="med" len="med"/>
+                    </a:lnB>
+                    <a:noFill/>
+                  </a:tcPr>
+                </a:tc>
+                <a:extLst>
+                  <a:ext uri="{0D108BD9-81ED-4DB2-BD59-A6C34878D82A}">
+                    <a16:rowId xmlns:a16="http://schemas.microsoft.com/office/drawing/2014/main" val="2506779841"/>
+                  </a:ext>
+                </a:extLst>
+              </a:tr>
+              <a:tr h="1201373">
+                <a:tc>
+                  <a:txBody>
+                    <a:bodyPr/>
+                    <a:lstStyle/>
+                    <a:p>
+                      <a:pPr rtl="0">
+                        <a:buNone/>
+                      </a:pPr>
+                      <a:r>
+                        <a:rPr lang="en-US" sz="1500" b="1">
+                          <a:solidFill>
+                            <a:srgbClr val="1F1F1F"/>
+                          </a:solidFill>
+                          <a:effectLst/>
+                          <a:latin typeface="Google Sans Text"/>
+                        </a:rPr>
+                        <a:t>Role Guarding</a:t>
+                      </a:r>
+                      <a:endParaRPr lang="en-US" sz="1500">
+                        <a:solidFill>
+                          <a:srgbClr val="1F1F1F"/>
+                        </a:solidFill>
+                        <a:effectLst/>
+                        <a:latin typeface="Google Sans Text"/>
+                      </a:endParaRPr>
+                    </a:p>
+                  </a:txBody>
+                  <a:tcPr marL="73751" marR="73751" marT="49168" marB="49168" anchor="ctr">
+                    <a:lnL w="7620" cap="flat" cmpd="sng" algn="ctr">
+                      <a:solidFill>
+                        <a:schemeClr val="bg1"/>
+                      </a:solidFill>
+                      <a:prstDash val="solid"/>
+                      <a:round/>
+                      <a:headEnd type="none" w="med" len="med"/>
+                      <a:tailEnd type="none" w="med" len="med"/>
+                    </a:lnL>
+                    <a:lnR w="7620" cap="flat" cmpd="sng" algn="ctr">
+                      <a:solidFill>
+                        <a:schemeClr val="bg1"/>
+                      </a:solidFill>
+                      <a:prstDash val="solid"/>
+                      <a:round/>
+                      <a:headEnd type="none" w="med" len="med"/>
+                      <a:tailEnd type="none" w="med" len="med"/>
+                    </a:lnR>
+                    <a:lnT w="7620" cap="flat" cmpd="sng" algn="ctr">
+                      <a:solidFill>
+                        <a:schemeClr val="bg1"/>
+                      </a:solidFill>
+                      <a:prstDash val="solid"/>
+                      <a:round/>
+                      <a:headEnd type="none" w="med" len="med"/>
+                      <a:tailEnd type="none" w="med" len="med"/>
+                    </a:lnT>
+                    <a:lnB w="7620" cap="flat" cmpd="sng" algn="ctr">
+                      <a:solidFill>
+                        <a:schemeClr val="bg1"/>
+                      </a:solidFill>
+                      <a:prstDash val="solid"/>
+                      <a:round/>
+                      <a:headEnd type="none" w="med" len="med"/>
+                      <a:tailEnd type="none" w="med" len="med"/>
+                    </a:lnB>
+                    <a:noFill/>
+                  </a:tcPr>
+                </a:tc>
+                <a:tc>
+                  <a:txBody>
+                    <a:bodyPr/>
+                    <a:lstStyle/>
+                    <a:p>
+                      <a:pPr rtl="0">
+                        <a:buNone/>
+                      </a:pPr>
+                      <a:r>
+                        <a:rPr lang="en-US" sz="1500" b="1">
+                          <a:solidFill>
+                            <a:srgbClr val="1F1F1F"/>
+                          </a:solidFill>
+                          <a:effectLst/>
+                          <a:latin typeface="Google Sans Text"/>
+                        </a:rPr>
+                        <a:t>Security.</a:t>
+                      </a:r>
+                      <a:r>
+                        <a:rPr lang="en-US" sz="1500">
+                          <a:solidFill>
+                            <a:srgbClr val="1F1F1F"/>
+                          </a:solidFill>
+                          <a:effectLst/>
+                          <a:latin typeface="Google Sans Text"/>
+                        </a:rPr>
+                        <a:t> A Technician cannot see the Admin panel; a Customer cannot assign jobs.</a:t>
+                      </a:r>
+                    </a:p>
+                  </a:txBody>
+                  <a:tcPr marL="73751" marR="73751" marT="49168" marB="49168" anchor="ctr">
+                    <a:lnL w="7620" cap="flat" cmpd="sng" algn="ctr">
+                      <a:solidFill>
+                        <a:schemeClr val="bg1"/>
+                      </a:solidFill>
+                      <a:prstDash val="solid"/>
+                      <a:round/>
+                      <a:headEnd type="none" w="med" len="med"/>
+                      <a:tailEnd type="none" w="med" len="med"/>
+                    </a:lnL>
+                    <a:lnR w="7620" cap="flat" cmpd="sng" algn="ctr">
+                      <a:solidFill>
+                        <a:schemeClr val="bg1"/>
+                      </a:solidFill>
+                      <a:prstDash val="solid"/>
+                      <a:round/>
+                      <a:headEnd type="none" w="med" len="med"/>
+                      <a:tailEnd type="none" w="med" len="med"/>
+                    </a:lnR>
+                    <a:lnT w="7620" cap="flat" cmpd="sng" algn="ctr">
+                      <a:solidFill>
+                        <a:schemeClr val="bg1"/>
+                      </a:solidFill>
+                      <a:prstDash val="solid"/>
+                      <a:round/>
+                      <a:headEnd type="none" w="med" len="med"/>
+                      <a:tailEnd type="none" w="med" len="med"/>
+                    </a:lnT>
+                    <a:lnB w="7620" cap="flat" cmpd="sng" algn="ctr">
+                      <a:solidFill>
+                        <a:schemeClr val="bg1"/>
+                      </a:solidFill>
+                      <a:prstDash val="solid"/>
+                      <a:round/>
+                      <a:headEnd type="none" w="med" len="med"/>
+                      <a:tailEnd type="none" w="med" len="med"/>
+                    </a:lnB>
+                    <a:noFill/>
+                  </a:tcPr>
+                </a:tc>
+                <a:extLst>
+                  <a:ext uri="{0D108BD9-81ED-4DB2-BD59-A6C34878D82A}">
+                    <a16:rowId xmlns:a16="http://schemas.microsoft.com/office/drawing/2014/main" val="2207590728"/>
+                  </a:ext>
+                </a:extLst>
+              </a:tr>
+              <a:tr h="1201373">
+                <a:tc>
+                  <a:txBody>
+                    <a:bodyPr/>
+                    <a:lstStyle/>
+                    <a:p>
+                      <a:pPr rtl="0">
+                        <a:buNone/>
+                      </a:pPr>
+                      <a:r>
+                        <a:rPr lang="en-US" sz="1500" b="1">
+                          <a:solidFill>
+                            <a:srgbClr val="1F1F1F"/>
+                          </a:solidFill>
+                          <a:effectLst/>
+                          <a:latin typeface="Google Sans Text"/>
+                        </a:rPr>
+                        <a:t>Email Verification</a:t>
+                      </a:r>
+                      <a:endParaRPr lang="en-US" sz="1500">
+                        <a:solidFill>
+                          <a:srgbClr val="1F1F1F"/>
+                        </a:solidFill>
+                        <a:effectLst/>
+                        <a:latin typeface="Google Sans Text"/>
+                      </a:endParaRPr>
+                    </a:p>
+                  </a:txBody>
+                  <a:tcPr marL="73751" marR="73751" marT="49168" marB="49168" anchor="ctr">
+                    <a:lnL w="7620" cap="flat" cmpd="sng" algn="ctr">
+                      <a:solidFill>
+                        <a:schemeClr val="bg1"/>
+                      </a:solidFill>
+                      <a:prstDash val="solid"/>
+                      <a:round/>
+                      <a:headEnd type="none" w="med" len="med"/>
+                      <a:tailEnd type="none" w="med" len="med"/>
+                    </a:lnL>
+                    <a:lnR w="7620" cap="flat" cmpd="sng" algn="ctr">
+                      <a:solidFill>
+                        <a:schemeClr val="bg1"/>
+                      </a:solidFill>
+                      <a:prstDash val="solid"/>
+                      <a:round/>
+                      <a:headEnd type="none" w="med" len="med"/>
+                      <a:tailEnd type="none" w="med" len="med"/>
+                    </a:lnR>
+                    <a:lnT w="7620" cap="flat" cmpd="sng" algn="ctr">
+                      <a:solidFill>
+                        <a:schemeClr val="bg1"/>
+                      </a:solidFill>
+                      <a:prstDash val="solid"/>
+                      <a:round/>
+                      <a:headEnd type="none" w="med" len="med"/>
+                      <a:tailEnd type="none" w="med" len="med"/>
+                    </a:lnT>
+                    <a:lnB w="7620" cap="flat" cmpd="sng" algn="ctr">
+                      <a:solidFill>
+                        <a:schemeClr val="bg1"/>
+                      </a:solidFill>
+                      <a:prstDash val="solid"/>
+                      <a:round/>
+                      <a:headEnd type="none" w="med" len="med"/>
+                      <a:tailEnd type="none" w="med" len="med"/>
+                    </a:lnB>
+                    <a:noFill/>
+                  </a:tcPr>
+                </a:tc>
+                <a:tc>
+                  <a:txBody>
+                    <a:bodyPr/>
+                    <a:lstStyle/>
+                    <a:p>
+                      <a:pPr rtl="0">
+                        <a:buNone/>
+                      </a:pPr>
+                      <a:r>
+                        <a:rPr lang="en-US" sz="1500" b="1">
+                          <a:solidFill>
+                            <a:srgbClr val="1F1F1F"/>
+                          </a:solidFill>
+                          <a:effectLst/>
+                          <a:latin typeface="Google Sans Text"/>
+                        </a:rPr>
+                        <a:t>Identity Assurance.</a:t>
+                      </a:r>
+                      <a:r>
+                        <a:rPr lang="en-US" sz="1500">
+                          <a:solidFill>
+                            <a:srgbClr val="1F1F1F"/>
+                          </a:solidFill>
+                          <a:effectLst/>
+                          <a:latin typeface="Google Sans Text"/>
+                        </a:rPr>
+                        <a:t> Ensures the user is reachable for invoices/notifications.</a:t>
+                      </a:r>
+                    </a:p>
+                  </a:txBody>
+                  <a:tcPr marL="73751" marR="73751" marT="49168" marB="49168" anchor="ctr">
+                    <a:lnL w="7620" cap="flat" cmpd="sng" algn="ctr">
+                      <a:solidFill>
+                        <a:schemeClr val="bg1"/>
+                      </a:solidFill>
+                      <a:prstDash val="solid"/>
+                      <a:round/>
+                      <a:headEnd type="none" w="med" len="med"/>
+                      <a:tailEnd type="none" w="med" len="med"/>
+                    </a:lnL>
+                    <a:lnR w="7620" cap="flat" cmpd="sng" algn="ctr">
+                      <a:solidFill>
+                        <a:schemeClr val="bg1"/>
+                      </a:solidFill>
+                      <a:prstDash val="solid"/>
+                      <a:round/>
+                      <a:headEnd type="none" w="med" len="med"/>
+                      <a:tailEnd type="none" w="med" len="med"/>
+                    </a:lnR>
+                    <a:lnT w="7620" cap="flat" cmpd="sng" algn="ctr">
+                      <a:solidFill>
+                        <a:schemeClr val="bg1"/>
+                      </a:solidFill>
+                      <a:prstDash val="solid"/>
+                      <a:round/>
+                      <a:headEnd type="none" w="med" len="med"/>
+                      <a:tailEnd type="none" w="med" len="med"/>
+                    </a:lnT>
+                    <a:lnB w="7620" cap="flat" cmpd="sng" algn="ctr">
+                      <a:solidFill>
+                        <a:schemeClr val="bg1"/>
+                      </a:solidFill>
+                      <a:prstDash val="solid"/>
+                      <a:round/>
+                      <a:headEnd type="none" w="med" len="med"/>
+                      <a:tailEnd type="none" w="med" len="med"/>
+                    </a:lnB>
+                    <a:noFill/>
+                  </a:tcPr>
+                </a:tc>
+                <a:extLst>
+                  <a:ext uri="{0D108BD9-81ED-4DB2-BD59-A6C34878D82A}">
+                    <a16:rowId xmlns:a16="http://schemas.microsoft.com/office/drawing/2014/main" val="1667979315"/>
+                  </a:ext>
+                </a:extLst>
+              </a:tr>
+              <a:tr h="1201373">
+                <a:tc>
+                  <a:txBody>
+                    <a:bodyPr/>
+                    <a:lstStyle/>
+                    <a:p>
+                      <a:pPr rtl="0">
+                        <a:buNone/>
+                      </a:pPr>
+                      <a:r>
+                        <a:rPr lang="en-US" sz="1500" b="1">
+                          <a:solidFill>
+                            <a:srgbClr val="1F1F1F"/>
+                          </a:solidFill>
+                          <a:effectLst/>
+                          <a:latin typeface="Google Sans Text"/>
+                        </a:rPr>
+                        <a:t>State Machine</a:t>
+                      </a:r>
+                      <a:endParaRPr lang="en-US" sz="1500">
+                        <a:solidFill>
+                          <a:srgbClr val="1F1F1F"/>
+                        </a:solidFill>
+                        <a:effectLst/>
+                        <a:latin typeface="Google Sans Text"/>
+                      </a:endParaRPr>
+                    </a:p>
+                  </a:txBody>
+                  <a:tcPr marL="73751" marR="73751" marT="49168" marB="49168" anchor="ctr">
+                    <a:lnL w="7620" cap="flat" cmpd="sng" algn="ctr">
+                      <a:solidFill>
+                        <a:schemeClr val="bg1"/>
+                      </a:solidFill>
+                      <a:prstDash val="solid"/>
+                      <a:round/>
+                      <a:headEnd type="none" w="med" len="med"/>
+                      <a:tailEnd type="none" w="med" len="med"/>
+                    </a:lnL>
+                    <a:lnR w="7620" cap="flat" cmpd="sng" algn="ctr">
+                      <a:solidFill>
+                        <a:schemeClr val="bg1"/>
+                      </a:solidFill>
+                      <a:prstDash val="solid"/>
+                      <a:round/>
+                      <a:headEnd type="none" w="med" len="med"/>
+                      <a:tailEnd type="none" w="med" len="med"/>
+                    </a:lnR>
+                    <a:lnT w="7620" cap="flat" cmpd="sng" algn="ctr">
+                      <a:solidFill>
+                        <a:schemeClr val="bg1"/>
+                      </a:solidFill>
+                      <a:prstDash val="solid"/>
+                      <a:round/>
+                      <a:headEnd type="none" w="med" len="med"/>
+                      <a:tailEnd type="none" w="med" len="med"/>
+                    </a:lnT>
+                    <a:lnB w="7620" cap="flat" cmpd="sng" algn="ctr">
+                      <a:solidFill>
+                        <a:schemeClr val="bg1"/>
+                      </a:solidFill>
+                      <a:prstDash val="solid"/>
+                      <a:round/>
+                      <a:headEnd type="none" w="med" len="med"/>
+                      <a:tailEnd type="none" w="med" len="med"/>
+                    </a:lnB>
+                    <a:noFill/>
+                  </a:tcPr>
+                </a:tc>
+                <a:tc>
+                  <a:txBody>
+                    <a:bodyPr/>
+                    <a:lstStyle/>
+                    <a:p>
+                      <a:pPr rtl="0">
+                        <a:buNone/>
+                      </a:pPr>
+                      <a:r>
+                        <a:rPr lang="en-US" sz="1500" b="1" dirty="0">
+                          <a:solidFill>
+                            <a:srgbClr val="1F1F1F"/>
+                          </a:solidFill>
+                          <a:effectLst/>
+                          <a:latin typeface="Google Sans Text"/>
+                        </a:rPr>
+                        <a:t>Process Integrity.</a:t>
+                      </a:r>
+                      <a:r>
+                        <a:rPr lang="en-US" sz="1500" dirty="0">
+                          <a:solidFill>
+                            <a:srgbClr val="1F1F1F"/>
+                          </a:solidFill>
+                          <a:effectLst/>
+                          <a:latin typeface="Google Sans Text"/>
+                        </a:rPr>
+                        <a:t> You can't "Complete" a job before you "Start" it.</a:t>
+                      </a:r>
+                    </a:p>
+                  </a:txBody>
+                  <a:tcPr marL="73751" marR="73751" marT="49168" marB="49168" anchor="ctr">
+                    <a:lnL w="7620" cap="flat" cmpd="sng" algn="ctr">
+                      <a:solidFill>
+                        <a:schemeClr val="bg1"/>
+                      </a:solidFill>
+                      <a:prstDash val="solid"/>
+                      <a:round/>
+                      <a:headEnd type="none" w="med" len="med"/>
+                      <a:tailEnd type="none" w="med" len="med"/>
+                    </a:lnL>
+                    <a:lnR w="7620" cap="flat" cmpd="sng" algn="ctr">
+                      <a:solidFill>
+                        <a:schemeClr val="bg1"/>
+                      </a:solidFill>
+                      <a:prstDash val="solid"/>
+                      <a:round/>
+                      <a:headEnd type="none" w="med" len="med"/>
+                      <a:tailEnd type="none" w="med" len="med"/>
+                    </a:lnR>
+                    <a:lnT w="7620" cap="flat" cmpd="sng" algn="ctr">
+                      <a:solidFill>
+                        <a:schemeClr val="bg1"/>
+                      </a:solidFill>
+                      <a:prstDash val="solid"/>
+                      <a:round/>
+                      <a:headEnd type="none" w="med" len="med"/>
+                      <a:tailEnd type="none" w="med" len="med"/>
+                    </a:lnT>
+                    <a:lnB w="7620" cap="flat" cmpd="sng" algn="ctr">
+                      <a:solidFill>
+                        <a:schemeClr val="bg1"/>
+                      </a:solidFill>
+                      <a:prstDash val="solid"/>
+                      <a:round/>
+                      <a:headEnd type="none" w="med" len="med"/>
+                      <a:tailEnd type="none" w="med" len="med"/>
+                    </a:lnB>
+                    <a:noFill/>
+                  </a:tcPr>
+                </a:tc>
+                <a:extLst>
+                  <a:ext uri="{0D108BD9-81ED-4DB2-BD59-A6C34878D82A}">
+                    <a16:rowId xmlns:a16="http://schemas.microsoft.com/office/drawing/2014/main" val="1570497494"/>
+                  </a:ext>
+                </a:extLst>
+              </a:tr>
+            </a:tbl>
+          </a:graphicData>
+        </a:graphic>
+      </p:graphicFrame>
     </p:spTree>
     <p:extLst>
       <p:ext uri="{BB962C8B-B14F-4D97-AF65-F5344CB8AC3E}">
-        <p14:creationId xmlns:p14="http://schemas.microsoft.com/office/powerpoint/2010/main" val="2662672783"/>
+        <p14:creationId xmlns:p14="http://schemas.microsoft.com/office/powerpoint/2010/main" val="3992535927"/>
       </p:ext>
     </p:extLst>
   </p:cSld>

</xml_diff>